<commit_message>
Expand SignalShield pitch explanations and add contact email
Co-authored-by: arena-agent <297053741+arena-agent@users.noreply.github.com>
</commit_message>
<xml_diff>
--- a/SignalShield_IEEE_APS_Ideathon_2026.pptx
+++ b/SignalShield_IEEE_APS_Ideathon_2026.pptx
@@ -578,7 +578,7 @@
           <a:lstStyle/>
           <a:p>
             <a:r>
-              <a:t>Storms can knock out towers. Families may lose calls, help, and warnings. We need to know which villages may go offline before danger arrives.</a:t>
+              <a:t>Storms can knock out towers. Families may lose calls, help, and warnings. A late warning gives people less time to act. We need to predict weak areas before danger arrives.</a:t>
             </a:r>
           </a:p>
         </p:txBody>
@@ -648,7 +648,7 @@
           <a:lstStyle/>
           <a:p>
             <a:r>
-              <a:t>Existing apps measure signal after people walk around. They need users in weak areas. SignalShield predicts outage risk and suggests one relay site.</a:t>
+              <a:t>Existing apps measure signal after people walk around. They need users in weak areas. SignalShield uses public data to predict which villages may lose service before a storm.</a:t>
             </a:r>
           </a:p>
         </p:txBody>
@@ -718,7 +718,7 @@
           <a:lstStyle/>
           <a:p>
             <a:r>
-              <a:t>Choose a village on the map. Turn off one tower to see red areas. The tool picks one relay spot to bring weak areas back into coverage.</a:t>
+              <a:t>Choose a village, then switch off a tower in the model. The map shows villages that lose signal, people affected, and one good relay location. Compare normal and disaster coverage.</a:t>
             </a:r>
           </a:p>
         </p:txBody>
@@ -788,7 +788,7 @@
           <a:lstStyle/>
           <a:p>
             <a:r>
-              <a:t>We use terrain and tower data to estimate radio coverage. RF checks include path loss, line of sight, Fresnel zone, antenna height, and gain.</a:t>
+              <a:t>Hills and distance can weaken radio signals. Path loss is signal drop over distance. Line of sight is a clear path. The Fresnel zone is space around that path. Height and gain help the signal reach further.</a:t>
             </a:r>
           </a:p>
         </p:txBody>
@@ -858,7 +858,7 @@
           <a:lstStyle/>
           <a:p>
             <a:r>
-              <a:t>SignalShield supports strong networks, safer villages, climate readiness, and learning. A pilot will measure the village, people reached, and relay cost.</a:t>
+              <a:t>SignalShield supports strong networks, safer villages, climate readiness, and learning. Better coverage planning helps warnings reach people. A pilot will report the village, people reached, and relay cost.</a:t>
             </a:r>
           </a:p>
         </p:txBody>
@@ -928,7 +928,7 @@
           <a:lstStyle/>
           <a:p>
             <a:r>
-              <a:t>We will test one village, work with a district disaster management authority, and then scale to flood-prone districts. We seek a pilot partner and data access.</a:t>
+              <a:t>We will test one village, work with a district disaster management authority, and then scale to flood-prone districts. Start small, measure results, then expand. We seek a pilot partner and data access.</a:t>
             </a:r>
           </a:p>
         </p:txBody>
@@ -4638,13 +4638,13 @@
               </a:spcAft>
             </a:pPr>
             <a:r>
-              <a:rPr sz="1550" b="1" i="0">
+              <a:rPr sz="1450" b="1">
                 <a:solidFill>
                   <a:srgbClr val="F3F7F9"/>
                 </a:solidFill>
                 <a:latin typeface="Aptos"/>
               </a:rPr>
-              <a:t>NithyaSri S · Preethika S</a:t>
+              <a:t>N.Sachin · NithyaSri S · Preethika S</a:t>
             </a:r>
           </a:p>
         </p:txBody>
@@ -5567,6 +5567,184 @@
           </a:p>
         </p:txBody>
       </p:sp>
+      <p:sp>
+        <p:nvSpPr>
+          <p:cNvPr id="23" name="Rounded Rectangle 22"/>
+          <p:cNvSpPr/>
+          <p:nvPr/>
+        </p:nvSpPr>
+        <p:spPr>
+          <a:xfrm>
+            <a:off x="749808" y="5257800"/>
+            <a:ext cx="5376672" cy="859536"/>
+          </a:xfrm>
+          <a:prstGeom prst="roundRect">
+            <a:avLst/>
+          </a:prstGeom>
+          <a:solidFill>
+            <a:srgbClr val="12283A"/>
+          </a:solidFill>
+          <a:ln w="10160">
+            <a:solidFill>
+              <a:srgbClr val="244054"/>
+            </a:solidFill>
+          </a:ln>
+        </p:spPr>
+        <p:style>
+          <a:lnRef idx="1">
+            <a:schemeClr val="accent1"/>
+          </a:lnRef>
+          <a:fillRef idx="3">
+            <a:schemeClr val="accent1"/>
+          </a:fillRef>
+          <a:effectRef idx="2">
+            <a:schemeClr val="accent1"/>
+          </a:effectRef>
+          <a:fontRef idx="minor">
+            <a:schemeClr val="lt1"/>
+          </a:fontRef>
+        </p:style>
+        <p:txBody>
+          <a:bodyPr rtlCol="0" anchor="ctr"/>
+          <a:lstStyle/>
+          <a:p>
+            <a:pPr algn="ctr"/>
+          </a:p>
+        </p:txBody>
+      </p:sp>
+      <p:sp>
+        <p:nvSpPr>
+          <p:cNvPr id="24" name="Rectangle 23"/>
+          <p:cNvSpPr/>
+          <p:nvPr/>
+        </p:nvSpPr>
+        <p:spPr>
+          <a:xfrm>
+            <a:off x="960120" y="5504688"/>
+            <a:ext cx="54864" cy="329184"/>
+          </a:xfrm>
+          <a:prstGeom prst="rect">
+            <a:avLst/>
+          </a:prstGeom>
+          <a:solidFill>
+            <a:srgbClr val="B9F36C"/>
+          </a:solidFill>
+          <a:ln>
+            <a:noFill/>
+          </a:ln>
+        </p:spPr>
+        <p:style>
+          <a:lnRef idx="1">
+            <a:schemeClr val="accent1"/>
+          </a:lnRef>
+          <a:fillRef idx="3">
+            <a:schemeClr val="accent1"/>
+          </a:fillRef>
+          <a:effectRef idx="2">
+            <a:schemeClr val="accent1"/>
+          </a:effectRef>
+          <a:fontRef idx="minor">
+            <a:schemeClr val="lt1"/>
+          </a:fontRef>
+        </p:style>
+        <p:txBody>
+          <a:bodyPr rtlCol="0" anchor="ctr"/>
+          <a:lstStyle/>
+          <a:p>
+            <a:pPr algn="ctr"/>
+          </a:p>
+        </p:txBody>
+      </p:sp>
+      <p:sp>
+        <p:nvSpPr>
+          <p:cNvPr id="25" name="TextBox 24"/>
+          <p:cNvSpPr txBox="1"/>
+          <p:nvPr/>
+        </p:nvSpPr>
+        <p:spPr>
+          <a:xfrm>
+            <a:off x="1170432" y="5321808"/>
+            <a:ext cx="4526280" cy="192024"/>
+          </a:xfrm>
+          <a:prstGeom prst="rect">
+            <a:avLst/>
+          </a:prstGeom>
+          <a:noFill/>
+        </p:spPr>
+        <p:txBody>
+          <a:bodyPr wrap="square" lIns="0" rIns="0" tIns="0" bIns="0" anchor="ctr">
+            <a:spAutoFit/>
+          </a:bodyPr>
+          <a:lstStyle/>
+          <a:p>
+            <a:pPr algn="l">
+              <a:lnSpc>
+                <a:spcPct val="98000"/>
+              </a:lnSpc>
+              <a:spcBef>
+                <a:spcPts val="0"/>
+              </a:spcBef>
+              <a:spcAft>
+                <a:spcPts val="0"/>
+              </a:spcAft>
+            </a:pPr>
+            <a:r>
+              <a:rPr sz="1050" b="1">
+                <a:solidFill>
+                  <a:srgbClr val="B9F36C"/>
+                </a:solidFill>
+                <a:latin typeface="Aptos"/>
+              </a:rPr>
+              <a:t>WHY IT MATTERS</a:t>
+            </a:r>
+          </a:p>
+        </p:txBody>
+      </p:sp>
+      <p:sp>
+        <p:nvSpPr>
+          <p:cNvPr id="26" name="TextBox 25"/>
+          <p:cNvSpPr txBox="1"/>
+          <p:nvPr/>
+        </p:nvSpPr>
+        <p:spPr>
+          <a:xfrm>
+            <a:off x="1170432" y="5541264"/>
+            <a:ext cx="4690872" cy="384048"/>
+          </a:xfrm>
+          <a:prstGeom prst="rect">
+            <a:avLst/>
+          </a:prstGeom>
+          <a:noFill/>
+        </p:spPr>
+        <p:txBody>
+          <a:bodyPr wrap="square" lIns="0" rIns="0" tIns="0" bIns="0" anchor="ctr">
+            <a:spAutoFit/>
+          </a:bodyPr>
+          <a:lstStyle/>
+          <a:p>
+            <a:pPr algn="l">
+              <a:lnSpc>
+                <a:spcPct val="98000"/>
+              </a:lnSpc>
+              <a:spcBef>
+                <a:spcPts val="0"/>
+              </a:spcBef>
+              <a:spcAft>
+                <a:spcPts val="0"/>
+              </a:spcAft>
+            </a:pPr>
+            <a:r>
+              <a:rPr sz="1550" b="1">
+                <a:solidFill>
+                  <a:srgbClr val="F3F7F9"/>
+                </a:solidFill>
+                <a:latin typeface="Aptos"/>
+              </a:rPr>
+              <a:t>A late warning gives families less time to act.</a:t>
+            </a:r>
+          </a:p>
+        </p:txBody>
+      </p:sp>
     </p:spTree>
   </p:cSld>
   <p:clrMapOvr>
@@ -7313,6 +7491,137 @@
           </a:p>
         </p:txBody>
       </p:sp>
+      <p:sp>
+        <p:nvSpPr>
+          <p:cNvPr id="43" name="Rounded Rectangle 42"/>
+          <p:cNvSpPr/>
+          <p:nvPr/>
+        </p:nvSpPr>
+        <p:spPr>
+          <a:xfrm>
+            <a:off x="914400" y="5577840"/>
+            <a:ext cx="5943600" cy="429768"/>
+          </a:xfrm>
+          <a:prstGeom prst="roundRect">
+            <a:avLst/>
+          </a:prstGeom>
+          <a:solidFill>
+            <a:srgbClr val="142B31"/>
+          </a:solidFill>
+          <a:ln>
+            <a:noFill/>
+          </a:ln>
+        </p:spPr>
+        <p:style>
+          <a:lnRef idx="1">
+            <a:schemeClr val="accent1"/>
+          </a:lnRef>
+          <a:fillRef idx="3">
+            <a:schemeClr val="accent1"/>
+          </a:fillRef>
+          <a:effectRef idx="2">
+            <a:schemeClr val="accent1"/>
+          </a:effectRef>
+          <a:fontRef idx="minor">
+            <a:schemeClr val="lt1"/>
+          </a:fontRef>
+        </p:style>
+        <p:txBody>
+          <a:bodyPr rtlCol="0" anchor="ctr"/>
+          <a:lstStyle/>
+          <a:p>
+            <a:pPr algn="ctr"/>
+          </a:p>
+        </p:txBody>
+      </p:sp>
+      <p:sp>
+        <p:nvSpPr>
+          <p:cNvPr id="44" name="Rectangle 43"/>
+          <p:cNvSpPr/>
+          <p:nvPr/>
+        </p:nvSpPr>
+        <p:spPr>
+          <a:xfrm>
+            <a:off x="914400" y="5577840"/>
+            <a:ext cx="50292" cy="429768"/>
+          </a:xfrm>
+          <a:prstGeom prst="rect">
+            <a:avLst/>
+          </a:prstGeom>
+          <a:solidFill>
+            <a:srgbClr val="B9F36C"/>
+          </a:solidFill>
+          <a:ln>
+            <a:noFill/>
+          </a:ln>
+        </p:spPr>
+        <p:style>
+          <a:lnRef idx="1">
+            <a:schemeClr val="accent1"/>
+          </a:lnRef>
+          <a:fillRef idx="3">
+            <a:schemeClr val="accent1"/>
+          </a:fillRef>
+          <a:effectRef idx="2">
+            <a:schemeClr val="accent1"/>
+          </a:effectRef>
+          <a:fontRef idx="minor">
+            <a:schemeClr val="lt1"/>
+          </a:fontRef>
+        </p:style>
+        <p:txBody>
+          <a:bodyPr rtlCol="0" anchor="ctr"/>
+          <a:lstStyle/>
+          <a:p>
+            <a:pPr algn="ctr"/>
+          </a:p>
+        </p:txBody>
+      </p:sp>
+      <p:sp>
+        <p:nvSpPr>
+          <p:cNvPr id="45" name="TextBox 44"/>
+          <p:cNvSpPr txBox="1"/>
+          <p:nvPr/>
+        </p:nvSpPr>
+        <p:spPr>
+          <a:xfrm>
+            <a:off x="1097280" y="5577840"/>
+            <a:ext cx="5577840" cy="429768"/>
+          </a:xfrm>
+          <a:prstGeom prst="rect">
+            <a:avLst/>
+          </a:prstGeom>
+          <a:noFill/>
+        </p:spPr>
+        <p:txBody>
+          <a:bodyPr wrap="square" lIns="0" rIns="0" tIns="0" bIns="0" anchor="ctr">
+            <a:spAutoFit/>
+          </a:bodyPr>
+          <a:lstStyle/>
+          <a:p>
+            <a:pPr algn="l">
+              <a:lnSpc>
+                <a:spcPct val="98000"/>
+              </a:lnSpc>
+              <a:spcBef>
+                <a:spcPts val="0"/>
+              </a:spcBef>
+              <a:spcAft>
+                <a:spcPts val="0"/>
+              </a:spcAft>
+            </a:pPr>
+            <a:r>
+              <a:rPr sz="1550" b="1">
+                <a:solidFill>
+                  <a:srgbClr val="B9F36C"/>
+                </a:solidFill>
+                <a:latin typeface="Aptos"/>
+              </a:rPr>
+              <a:t>Signal today is not a forecast for tomorrow.</a:t>
+            </a:r>
+          </a:p>
+        </p:txBody>
+      </p:sp>
     </p:spTree>
   </p:cSld>
   <p:clrMapOvr>
@@ -9596,298 +9905,6 @@
           </a:p>
         </p:txBody>
       </p:sp>
-      <p:sp>
-        <p:nvSpPr>
-          <p:cNvPr id="59" name="Rounded Rectangle 58"/>
-          <p:cNvSpPr/>
-          <p:nvPr/>
-        </p:nvSpPr>
-        <p:spPr>
-          <a:xfrm>
-            <a:off x="658368" y="3749039"/>
-            <a:ext cx="5230368" cy="2395728"/>
-          </a:xfrm>
-          <a:prstGeom prst="roundRect">
-            <a:avLst/>
-          </a:prstGeom>
-          <a:solidFill>
-            <a:srgbClr val="0A1B2A"/>
-          </a:solidFill>
-          <a:ln w="15875">
-            <a:solidFill>
-              <a:srgbClr val="74D7A5"/>
-            </a:solidFill>
-            <a:prstDash val="dash"/>
-          </a:ln>
-        </p:spPr>
-        <p:style>
-          <a:lnRef idx="1">
-            <a:schemeClr val="accent1"/>
-          </a:lnRef>
-          <a:fillRef idx="3">
-            <a:schemeClr val="accent1"/>
-          </a:fillRef>
-          <a:effectRef idx="2">
-            <a:schemeClr val="accent1"/>
-          </a:effectRef>
-          <a:fontRef idx="minor">
-            <a:schemeClr val="lt1"/>
-          </a:fontRef>
-        </p:style>
-        <p:txBody>
-          <a:bodyPr rtlCol="0" anchor="ctr"/>
-          <a:lstStyle/>
-          <a:p>
-            <a:pPr algn="ctr"/>
-          </a:p>
-        </p:txBody>
-      </p:sp>
-      <p:sp>
-        <p:nvSpPr>
-          <p:cNvPr id="60" name="Rounded Rectangle 59"/>
-          <p:cNvSpPr/>
-          <p:nvPr/>
-        </p:nvSpPr>
-        <p:spPr>
-          <a:xfrm>
-            <a:off x="950976" y="4389120"/>
-            <a:ext cx="1051560" cy="859536"/>
-          </a:xfrm>
-          <a:prstGeom prst="roundRect">
-            <a:avLst/>
-          </a:prstGeom>
-          <a:noFill/>
-          <a:ln w="17145">
-            <a:solidFill>
-              <a:srgbClr val="9AAFC0"/>
-            </a:solidFill>
-          </a:ln>
-        </p:spPr>
-        <p:style>
-          <a:lnRef idx="1">
-            <a:schemeClr val="accent1"/>
-          </a:lnRef>
-          <a:fillRef idx="3">
-            <a:schemeClr val="accent1"/>
-          </a:fillRef>
-          <a:effectRef idx="2">
-            <a:schemeClr val="accent1"/>
-          </a:effectRef>
-          <a:fontRef idx="minor">
-            <a:schemeClr val="lt1"/>
-          </a:fontRef>
-        </p:style>
-        <p:txBody>
-          <a:bodyPr rtlCol="0" anchor="ctr"/>
-          <a:lstStyle/>
-          <a:p>
-            <a:pPr algn="ctr"/>
-          </a:p>
-        </p:txBody>
-      </p:sp>
-      <p:cxnSp>
-        <p:nvCxnSpPr>
-          <p:cNvPr id="61" name="Connector 60"/>
-          <p:cNvCxnSpPr/>
-          <p:nvPr/>
-        </p:nvCxnSpPr>
-        <p:spPr>
-          <a:xfrm flipV="1">
-            <a:off x="1051560" y="4672584"/>
-            <a:ext cx="347472" cy="338328"/>
-          </a:xfrm>
-          <a:prstGeom prst="line">
-            <a:avLst/>
-          </a:prstGeom>
-          <a:ln w="15240">
-            <a:solidFill>
-              <a:srgbClr val="74D7A5"/>
-            </a:solidFill>
-          </a:ln>
-        </p:spPr>
-        <p:style>
-          <a:lnRef idx="2">
-            <a:schemeClr val="accent1"/>
-          </a:lnRef>
-          <a:fillRef idx="0">
-            <a:schemeClr val="accent1"/>
-          </a:fillRef>
-          <a:effectRef idx="1">
-            <a:schemeClr val="accent1"/>
-          </a:effectRef>
-          <a:fontRef idx="minor">
-            <a:schemeClr val="tx1"/>
-          </a:fontRef>
-        </p:style>
-      </p:cxnSp>
-      <p:cxnSp>
-        <p:nvCxnSpPr>
-          <p:cNvPr id="62" name="Connector 61"/>
-          <p:cNvCxnSpPr/>
-          <p:nvPr/>
-        </p:nvCxnSpPr>
-        <p:spPr>
-          <a:xfrm>
-            <a:off x="1399032" y="4672584"/>
-            <a:ext cx="246888" cy="237744"/>
-          </a:xfrm>
-          <a:prstGeom prst="line">
-            <a:avLst/>
-          </a:prstGeom>
-          <a:ln w="15240">
-            <a:solidFill>
-              <a:srgbClr val="74D7A5"/>
-            </a:solidFill>
-          </a:ln>
-        </p:spPr>
-        <p:style>
-          <a:lnRef idx="2">
-            <a:schemeClr val="accent1"/>
-          </a:lnRef>
-          <a:fillRef idx="0">
-            <a:schemeClr val="accent1"/>
-          </a:fillRef>
-          <a:effectRef idx="1">
-            <a:schemeClr val="accent1"/>
-          </a:effectRef>
-          <a:fontRef idx="minor">
-            <a:schemeClr val="tx1"/>
-          </a:fontRef>
-        </p:style>
-      </p:cxnSp>
-      <p:sp>
-        <p:nvSpPr>
-          <p:cNvPr id="63" name="Oval 62"/>
-          <p:cNvSpPr/>
-          <p:nvPr/>
-        </p:nvSpPr>
-        <p:spPr>
-          <a:xfrm>
-            <a:off x="1170432" y="4517136"/>
-            <a:ext cx="82296" cy="82296"/>
-          </a:xfrm>
-          <a:prstGeom prst="ellipse">
-            <a:avLst/>
-          </a:prstGeom>
-          <a:solidFill>
-            <a:srgbClr val="B9F36C"/>
-          </a:solidFill>
-          <a:ln>
-            <a:noFill/>
-          </a:ln>
-        </p:spPr>
-        <p:style>
-          <a:lnRef idx="1">
-            <a:schemeClr val="accent1"/>
-          </a:lnRef>
-          <a:fillRef idx="3">
-            <a:schemeClr val="accent1"/>
-          </a:fillRef>
-          <a:effectRef idx="2">
-            <a:schemeClr val="accent1"/>
-          </a:effectRef>
-          <a:fontRef idx="minor">
-            <a:schemeClr val="lt1"/>
-          </a:fontRef>
-        </p:style>
-        <p:txBody>
-          <a:bodyPr rtlCol="0" anchor="ctr"/>
-          <a:lstStyle/>
-          <a:p>
-            <a:pPr algn="ctr"/>
-          </a:p>
-        </p:txBody>
-      </p:sp>
-      <p:sp>
-        <p:nvSpPr>
-          <p:cNvPr id="64" name="TextBox 63"/>
-          <p:cNvSpPr txBox="1"/>
-          <p:nvPr/>
-        </p:nvSpPr>
-        <p:spPr>
-          <a:xfrm>
-            <a:off x="2267712" y="4361688"/>
-            <a:ext cx="3063240" cy="356616"/>
-          </a:xfrm>
-          <a:prstGeom prst="rect">
-            <a:avLst/>
-          </a:prstGeom>
-          <a:noFill/>
-        </p:spPr>
-        <p:txBody>
-          <a:bodyPr wrap="square" lIns="0" rIns="0" tIns="0" bIns="0" anchor="ctr">
-            <a:spAutoFit/>
-          </a:bodyPr>
-          <a:lstStyle/>
-          <a:p>
-            <a:pPr algn="l">
-              <a:lnSpc>
-                <a:spcPct val="98000"/>
-              </a:lnSpc>
-              <a:spcBef>
-                <a:spcPts val="0"/>
-              </a:spcBef>
-              <a:spcAft>
-                <a:spcPts val="0"/>
-              </a:spcAft>
-            </a:pPr>
-            <a:r>
-              <a:rPr sz="1750" b="1" i="0">
-                <a:solidFill>
-                  <a:srgbClr val="F3F7F9"/>
-                </a:solidFill>
-                <a:latin typeface="Aptos"/>
-              </a:rPr>
-              <a:t>APP DEMO</a:t>
-            </a:r>
-          </a:p>
-        </p:txBody>
-      </p:sp>
-      <p:sp>
-        <p:nvSpPr>
-          <p:cNvPr id="65" name="TextBox 64"/>
-          <p:cNvSpPr txBox="1"/>
-          <p:nvPr/>
-        </p:nvSpPr>
-        <p:spPr>
-          <a:xfrm>
-            <a:off x="2267712" y="4773168"/>
-            <a:ext cx="3246120" cy="539496"/>
-          </a:xfrm>
-          <a:prstGeom prst="rect">
-            <a:avLst/>
-          </a:prstGeom>
-          <a:noFill/>
-        </p:spPr>
-        <p:txBody>
-          <a:bodyPr wrap="square" lIns="0" rIns="0" tIns="0" bIns="0" anchor="ctr">
-            <a:spAutoFit/>
-          </a:bodyPr>
-          <a:lstStyle/>
-          <a:p>
-            <a:pPr algn="l">
-              <a:lnSpc>
-                <a:spcPct val="98000"/>
-              </a:lnSpc>
-              <a:spcBef>
-                <a:spcPts val="0"/>
-              </a:spcBef>
-              <a:spcAft>
-                <a:spcPts val="0"/>
-              </a:spcAft>
-            </a:pPr>
-            <a:r>
-              <a:rPr sz="1510" b="0" i="0">
-                <a:solidFill>
-                  <a:srgbClr val="9AAFC0"/>
-                </a:solidFill>
-                <a:latin typeface="Aptos"/>
-              </a:rPr>
-              <a:t>Replace with your live app capture</a:t>
-            </a:r>
-          </a:p>
-        </p:txBody>
-      </p:sp>
       <p:pic>
         <p:nvPicPr>
           <p:cNvPr id="66" name="Picture 65" descr="slide4_solution_crop.jpg"/>
@@ -9952,6 +9969,448 @@
           <a:lstStyle/>
           <a:p>
             <a:pPr algn="ctr"/>
+          </a:p>
+        </p:txBody>
+      </p:sp>
+      <p:sp>
+        <p:nvSpPr>
+          <p:cNvPr id="68" name="Rounded Rectangle 67"/>
+          <p:cNvSpPr/>
+          <p:nvPr/>
+        </p:nvSpPr>
+        <p:spPr>
+          <a:xfrm>
+            <a:off x="658368" y="3749039"/>
+            <a:ext cx="5230368" cy="2395728"/>
+          </a:xfrm>
+          <a:prstGeom prst="roundRect">
+            <a:avLst/>
+          </a:prstGeom>
+          <a:solidFill>
+            <a:srgbClr val="0D2030"/>
+          </a:solidFill>
+          <a:ln w="11430">
+            <a:solidFill>
+              <a:srgbClr val="244054"/>
+            </a:solidFill>
+          </a:ln>
+        </p:spPr>
+        <p:style>
+          <a:lnRef idx="1">
+            <a:schemeClr val="accent1"/>
+          </a:lnRef>
+          <a:fillRef idx="3">
+            <a:schemeClr val="accent1"/>
+          </a:fillRef>
+          <a:effectRef idx="2">
+            <a:schemeClr val="accent1"/>
+          </a:effectRef>
+          <a:fontRef idx="minor">
+            <a:schemeClr val="lt1"/>
+          </a:fontRef>
+        </p:style>
+        <p:txBody>
+          <a:bodyPr rtlCol="0" anchor="ctr"/>
+          <a:lstStyle/>
+          <a:p>
+            <a:pPr algn="ctr"/>
+          </a:p>
+        </p:txBody>
+      </p:sp>
+      <p:sp>
+        <p:nvSpPr>
+          <p:cNvPr id="69" name="Rectangle 68"/>
+          <p:cNvSpPr/>
+          <p:nvPr/>
+        </p:nvSpPr>
+        <p:spPr>
+          <a:xfrm>
+            <a:off x="658368" y="3749039"/>
+            <a:ext cx="50292" cy="2395728"/>
+          </a:xfrm>
+          <a:prstGeom prst="rect">
+            <a:avLst/>
+          </a:prstGeom>
+          <a:solidFill>
+            <a:srgbClr val="B9F36C"/>
+          </a:solidFill>
+          <a:ln>
+            <a:noFill/>
+          </a:ln>
+        </p:spPr>
+        <p:style>
+          <a:lnRef idx="1">
+            <a:schemeClr val="accent1"/>
+          </a:lnRef>
+          <a:fillRef idx="3">
+            <a:schemeClr val="accent1"/>
+          </a:fillRef>
+          <a:effectRef idx="2">
+            <a:schemeClr val="accent1"/>
+          </a:effectRef>
+          <a:fontRef idx="minor">
+            <a:schemeClr val="lt1"/>
+          </a:fontRef>
+        </p:style>
+        <p:txBody>
+          <a:bodyPr rtlCol="0" anchor="ctr"/>
+          <a:lstStyle/>
+          <a:p>
+            <a:pPr algn="ctr"/>
+          </a:p>
+        </p:txBody>
+      </p:sp>
+      <p:sp>
+        <p:nvSpPr>
+          <p:cNvPr id="70" name="TextBox 69"/>
+          <p:cNvSpPr txBox="1"/>
+          <p:nvPr/>
+        </p:nvSpPr>
+        <p:spPr>
+          <a:xfrm>
+            <a:off x="932688" y="3858768"/>
+            <a:ext cx="4526280" cy="310896"/>
+          </a:xfrm>
+          <a:prstGeom prst="rect">
+            <a:avLst/>
+          </a:prstGeom>
+          <a:noFill/>
+        </p:spPr>
+        <p:txBody>
+          <a:bodyPr wrap="square" lIns="0" rIns="0" tIns="0" bIns="0" anchor="ctr">
+            <a:spAutoFit/>
+          </a:bodyPr>
+          <a:lstStyle/>
+          <a:p>
+            <a:pPr algn="l">
+              <a:lnSpc>
+                <a:spcPct val="98000"/>
+              </a:lnSpc>
+              <a:spcBef>
+                <a:spcPts val="0"/>
+              </a:spcBef>
+              <a:spcAft>
+                <a:spcPts val="0"/>
+              </a:spcAft>
+            </a:pPr>
+            <a:r>
+              <a:rPr sz="1750" b="1">
+                <a:solidFill>
+                  <a:srgbClr val="B9F36C"/>
+                </a:solidFill>
+                <a:latin typeface="Aptos"/>
+              </a:rPr>
+              <a:t>WHAT YOU SEE</a:t>
+            </a:r>
+          </a:p>
+        </p:txBody>
+      </p:sp>
+      <p:sp>
+        <p:nvSpPr>
+          <p:cNvPr id="71" name="Oval 70"/>
+          <p:cNvSpPr/>
+          <p:nvPr/>
+        </p:nvSpPr>
+        <p:spPr>
+          <a:xfrm>
+            <a:off x="969264" y="4370832"/>
+            <a:ext cx="146304" cy="146304"/>
+          </a:xfrm>
+          <a:prstGeom prst="ellipse">
+            <a:avLst/>
+          </a:prstGeom>
+          <a:solidFill>
+            <a:srgbClr val="B9F36C"/>
+          </a:solidFill>
+          <a:ln>
+            <a:noFill/>
+          </a:ln>
+        </p:spPr>
+        <p:style>
+          <a:lnRef idx="1">
+            <a:schemeClr val="accent1"/>
+          </a:lnRef>
+          <a:fillRef idx="3">
+            <a:schemeClr val="accent1"/>
+          </a:fillRef>
+          <a:effectRef idx="2">
+            <a:schemeClr val="accent1"/>
+          </a:effectRef>
+          <a:fontRef idx="minor">
+            <a:schemeClr val="lt1"/>
+          </a:fontRef>
+        </p:style>
+        <p:txBody>
+          <a:bodyPr rtlCol="0" anchor="ctr"/>
+          <a:lstStyle/>
+          <a:p>
+            <a:pPr algn="ctr"/>
+          </a:p>
+        </p:txBody>
+      </p:sp>
+      <p:sp>
+        <p:nvSpPr>
+          <p:cNvPr id="72" name="TextBox 71"/>
+          <p:cNvSpPr txBox="1"/>
+          <p:nvPr/>
+        </p:nvSpPr>
+        <p:spPr>
+          <a:xfrm>
+            <a:off x="1261872" y="4297680"/>
+            <a:ext cx="4224528" cy="310896"/>
+          </a:xfrm>
+          <a:prstGeom prst="rect">
+            <a:avLst/>
+          </a:prstGeom>
+          <a:noFill/>
+        </p:spPr>
+        <p:txBody>
+          <a:bodyPr wrap="square" lIns="0" rIns="0" tIns="0" bIns="0" anchor="ctr">
+            <a:spAutoFit/>
+          </a:bodyPr>
+          <a:lstStyle/>
+          <a:p>
+            <a:pPr algn="l">
+              <a:lnSpc>
+                <a:spcPct val="98000"/>
+              </a:lnSpc>
+              <a:spcBef>
+                <a:spcPts val="0"/>
+              </a:spcBef>
+              <a:spcAft>
+                <a:spcPts val="0"/>
+              </a:spcAft>
+            </a:pPr>
+            <a:r>
+              <a:rPr sz="1650" b="1">
+                <a:solidFill>
+                  <a:srgbClr val="F3F7F9"/>
+                </a:solidFill>
+                <a:latin typeface="Aptos"/>
+              </a:rPr>
+              <a:t>Villages that lose signal</a:t>
+            </a:r>
+          </a:p>
+        </p:txBody>
+      </p:sp>
+      <p:sp>
+        <p:nvSpPr>
+          <p:cNvPr id="73" name="Oval 72"/>
+          <p:cNvSpPr/>
+          <p:nvPr/>
+        </p:nvSpPr>
+        <p:spPr>
+          <a:xfrm>
+            <a:off x="969264" y="4745736"/>
+            <a:ext cx="146304" cy="146304"/>
+          </a:xfrm>
+          <a:prstGeom prst="ellipse">
+            <a:avLst/>
+          </a:prstGeom>
+          <a:solidFill>
+            <a:srgbClr val="B9F36C"/>
+          </a:solidFill>
+          <a:ln>
+            <a:noFill/>
+          </a:ln>
+        </p:spPr>
+        <p:style>
+          <a:lnRef idx="1">
+            <a:schemeClr val="accent1"/>
+          </a:lnRef>
+          <a:fillRef idx="3">
+            <a:schemeClr val="accent1"/>
+          </a:fillRef>
+          <a:effectRef idx="2">
+            <a:schemeClr val="accent1"/>
+          </a:effectRef>
+          <a:fontRef idx="minor">
+            <a:schemeClr val="lt1"/>
+          </a:fontRef>
+        </p:style>
+        <p:txBody>
+          <a:bodyPr rtlCol="0" anchor="ctr"/>
+          <a:lstStyle/>
+          <a:p>
+            <a:pPr algn="ctr"/>
+          </a:p>
+        </p:txBody>
+      </p:sp>
+      <p:sp>
+        <p:nvSpPr>
+          <p:cNvPr id="74" name="TextBox 73"/>
+          <p:cNvSpPr txBox="1"/>
+          <p:nvPr/>
+        </p:nvSpPr>
+        <p:spPr>
+          <a:xfrm>
+            <a:off x="1261872" y="4672584"/>
+            <a:ext cx="4224528" cy="310896"/>
+          </a:xfrm>
+          <a:prstGeom prst="rect">
+            <a:avLst/>
+          </a:prstGeom>
+          <a:noFill/>
+        </p:spPr>
+        <p:txBody>
+          <a:bodyPr wrap="square" lIns="0" rIns="0" tIns="0" bIns="0" anchor="ctr">
+            <a:spAutoFit/>
+          </a:bodyPr>
+          <a:lstStyle/>
+          <a:p>
+            <a:pPr algn="l">
+              <a:lnSpc>
+                <a:spcPct val="98000"/>
+              </a:lnSpc>
+              <a:spcBef>
+                <a:spcPts val="0"/>
+              </a:spcBef>
+              <a:spcAft>
+                <a:spcPts val="0"/>
+              </a:spcAft>
+            </a:pPr>
+            <a:r>
+              <a:rPr sz="1650" b="1">
+                <a:solidFill>
+                  <a:srgbClr val="F3F7F9"/>
+                </a:solidFill>
+                <a:latin typeface="Aptos"/>
+              </a:rPr>
+              <a:t>People affected by each outage</a:t>
+            </a:r>
+          </a:p>
+        </p:txBody>
+      </p:sp>
+      <p:sp>
+        <p:nvSpPr>
+          <p:cNvPr id="75" name="Oval 74"/>
+          <p:cNvSpPr/>
+          <p:nvPr/>
+        </p:nvSpPr>
+        <p:spPr>
+          <a:xfrm>
+            <a:off x="969264" y="5120640"/>
+            <a:ext cx="146304" cy="146304"/>
+          </a:xfrm>
+          <a:prstGeom prst="ellipse">
+            <a:avLst/>
+          </a:prstGeom>
+          <a:solidFill>
+            <a:srgbClr val="B9F36C"/>
+          </a:solidFill>
+          <a:ln>
+            <a:noFill/>
+          </a:ln>
+        </p:spPr>
+        <p:style>
+          <a:lnRef idx="1">
+            <a:schemeClr val="accent1"/>
+          </a:lnRef>
+          <a:fillRef idx="3">
+            <a:schemeClr val="accent1"/>
+          </a:fillRef>
+          <a:effectRef idx="2">
+            <a:schemeClr val="accent1"/>
+          </a:effectRef>
+          <a:fontRef idx="minor">
+            <a:schemeClr val="lt1"/>
+          </a:fontRef>
+        </p:style>
+        <p:txBody>
+          <a:bodyPr rtlCol="0" anchor="ctr"/>
+          <a:lstStyle/>
+          <a:p>
+            <a:pPr algn="ctr"/>
+          </a:p>
+        </p:txBody>
+      </p:sp>
+      <p:sp>
+        <p:nvSpPr>
+          <p:cNvPr id="76" name="TextBox 75"/>
+          <p:cNvSpPr txBox="1"/>
+          <p:nvPr/>
+        </p:nvSpPr>
+        <p:spPr>
+          <a:xfrm>
+            <a:off x="1261872" y="5047488"/>
+            <a:ext cx="4224528" cy="310896"/>
+          </a:xfrm>
+          <a:prstGeom prst="rect">
+            <a:avLst/>
+          </a:prstGeom>
+          <a:noFill/>
+        </p:spPr>
+        <p:txBody>
+          <a:bodyPr wrap="square" lIns="0" rIns="0" tIns="0" bIns="0" anchor="ctr">
+            <a:spAutoFit/>
+          </a:bodyPr>
+          <a:lstStyle/>
+          <a:p>
+            <a:pPr algn="l">
+              <a:lnSpc>
+                <a:spcPct val="98000"/>
+              </a:lnSpc>
+              <a:spcBef>
+                <a:spcPts val="0"/>
+              </a:spcBef>
+              <a:spcAft>
+                <a:spcPts val="0"/>
+              </a:spcAft>
+            </a:pPr>
+            <a:r>
+              <a:rPr sz="1650" b="1">
+                <a:solidFill>
+                  <a:srgbClr val="F3F7F9"/>
+                </a:solidFill>
+                <a:latin typeface="Aptos"/>
+              </a:rPr>
+              <a:t>Best place for one relay</a:t>
+            </a:r>
+          </a:p>
+        </p:txBody>
+      </p:sp>
+      <p:sp>
+        <p:nvSpPr>
+          <p:cNvPr id="77" name="TextBox 76"/>
+          <p:cNvSpPr txBox="1"/>
+          <p:nvPr/>
+        </p:nvSpPr>
+        <p:spPr>
+          <a:xfrm>
+            <a:off x="932688" y="5541264"/>
+            <a:ext cx="4626864" cy="356616"/>
+          </a:xfrm>
+          <a:prstGeom prst="rect">
+            <a:avLst/>
+          </a:prstGeom>
+          <a:noFill/>
+        </p:spPr>
+        <p:txBody>
+          <a:bodyPr wrap="square" lIns="0" rIns="0" tIns="0" bIns="0" anchor="ctr">
+            <a:spAutoFit/>
+          </a:bodyPr>
+          <a:lstStyle/>
+          <a:p>
+            <a:pPr algn="l">
+              <a:lnSpc>
+                <a:spcPct val="98000"/>
+              </a:lnSpc>
+              <a:spcBef>
+                <a:spcPts val="0"/>
+              </a:spcBef>
+              <a:spcAft>
+                <a:spcPts val="0"/>
+              </a:spcAft>
+            </a:pPr>
+            <a:r>
+              <a:rPr sz="1460" b="1">
+                <a:solidFill>
+                  <a:srgbClr val="74D7A5"/>
+                </a:solidFill>
+                <a:latin typeface="Aptos"/>
+              </a:rPr>
+              <a:t>Compare normal and disaster coverage.</a:t>
+            </a:r>
           </a:p>
         </p:txBody>
       </p:sp>
@@ -11291,491 +11750,6 @@
       </p:sp>
       <p:sp>
         <p:nvSpPr>
-          <p:cNvPr id="33" name="Rounded Rectangle 32"/>
-          <p:cNvSpPr/>
-          <p:nvPr/>
-        </p:nvSpPr>
-        <p:spPr>
-          <a:xfrm>
-            <a:off x="2049779" y="4462272"/>
-            <a:ext cx="1417320" cy="457200"/>
-          </a:xfrm>
-          <a:prstGeom prst="roundRect">
-            <a:avLst/>
-          </a:prstGeom>
-          <a:solidFill>
-            <a:srgbClr val="102738"/>
-          </a:solidFill>
-          <a:ln w="10160">
-            <a:solidFill>
-              <a:srgbClr val="244054"/>
-            </a:solidFill>
-          </a:ln>
-        </p:spPr>
-        <p:style>
-          <a:lnRef idx="1">
-            <a:schemeClr val="accent1"/>
-          </a:lnRef>
-          <a:fillRef idx="3">
-            <a:schemeClr val="accent1"/>
-          </a:fillRef>
-          <a:effectRef idx="2">
-            <a:schemeClr val="accent1"/>
-          </a:effectRef>
-          <a:fontRef idx="minor">
-            <a:schemeClr val="lt1"/>
-          </a:fontRef>
-        </p:style>
-        <p:txBody>
-          <a:bodyPr rtlCol="0" anchor="ctr"/>
-          <a:lstStyle/>
-          <a:p>
-            <a:pPr algn="ctr"/>
-          </a:p>
-        </p:txBody>
-      </p:sp>
-      <p:sp>
-        <p:nvSpPr>
-          <p:cNvPr id="34" name="TextBox 33"/>
-          <p:cNvSpPr txBox="1"/>
-          <p:nvPr/>
-        </p:nvSpPr>
-        <p:spPr>
-          <a:xfrm>
-            <a:off x="2095499" y="4471416"/>
-            <a:ext cx="1325880" cy="438912"/>
-          </a:xfrm>
-          <a:prstGeom prst="rect">
-            <a:avLst/>
-          </a:prstGeom>
-          <a:noFill/>
-        </p:spPr>
-        <p:txBody>
-          <a:bodyPr wrap="square" lIns="0" rIns="0" tIns="0" bIns="0" anchor="ctr">
-            <a:spAutoFit/>
-          </a:bodyPr>
-          <a:lstStyle/>
-          <a:p>
-            <a:pPr algn="ctr">
-              <a:lnSpc>
-                <a:spcPct val="98000"/>
-              </a:lnSpc>
-              <a:spcBef>
-                <a:spcPts val="0"/>
-              </a:spcBef>
-              <a:spcAft>
-                <a:spcPts val="0"/>
-              </a:spcAft>
-            </a:pPr>
-            <a:r>
-              <a:rPr sz="1370" b="1" i="0">
-                <a:solidFill>
-                  <a:srgbClr val="F3F7F9"/>
-                </a:solidFill>
-                <a:latin typeface="Aptos"/>
-              </a:rPr>
-              <a:t>Path loss</a:t>
-            </a:r>
-          </a:p>
-        </p:txBody>
-      </p:sp>
-      <p:sp>
-        <p:nvSpPr>
-          <p:cNvPr id="35" name="Rounded Rectangle 34"/>
-          <p:cNvSpPr/>
-          <p:nvPr/>
-        </p:nvSpPr>
-        <p:spPr>
-          <a:xfrm>
-            <a:off x="3613403" y="4462272"/>
-            <a:ext cx="1627632" cy="457200"/>
-          </a:xfrm>
-          <a:prstGeom prst="roundRect">
-            <a:avLst/>
-          </a:prstGeom>
-          <a:solidFill>
-            <a:srgbClr val="102738"/>
-          </a:solidFill>
-          <a:ln w="10160">
-            <a:solidFill>
-              <a:srgbClr val="244054"/>
-            </a:solidFill>
-          </a:ln>
-        </p:spPr>
-        <p:style>
-          <a:lnRef idx="1">
-            <a:schemeClr val="accent1"/>
-          </a:lnRef>
-          <a:fillRef idx="3">
-            <a:schemeClr val="accent1"/>
-          </a:fillRef>
-          <a:effectRef idx="2">
-            <a:schemeClr val="accent1"/>
-          </a:effectRef>
-          <a:fontRef idx="minor">
-            <a:schemeClr val="lt1"/>
-          </a:fontRef>
-        </p:style>
-        <p:txBody>
-          <a:bodyPr rtlCol="0" anchor="ctr"/>
-          <a:lstStyle/>
-          <a:p>
-            <a:pPr algn="ctr"/>
-          </a:p>
-        </p:txBody>
-      </p:sp>
-      <p:sp>
-        <p:nvSpPr>
-          <p:cNvPr id="36" name="TextBox 35"/>
-          <p:cNvSpPr txBox="1"/>
-          <p:nvPr/>
-        </p:nvSpPr>
-        <p:spPr>
-          <a:xfrm>
-            <a:off x="3659123" y="4471416"/>
-            <a:ext cx="1536192" cy="438912"/>
-          </a:xfrm>
-          <a:prstGeom prst="rect">
-            <a:avLst/>
-          </a:prstGeom>
-          <a:noFill/>
-        </p:spPr>
-        <p:txBody>
-          <a:bodyPr wrap="square" lIns="0" rIns="0" tIns="0" bIns="0" anchor="ctr">
-            <a:spAutoFit/>
-          </a:bodyPr>
-          <a:lstStyle/>
-          <a:p>
-            <a:pPr algn="ctr">
-              <a:lnSpc>
-                <a:spcPct val="98000"/>
-              </a:lnSpc>
-              <a:spcBef>
-                <a:spcPts val="0"/>
-              </a:spcBef>
-              <a:spcAft>
-                <a:spcPts val="0"/>
-              </a:spcAft>
-            </a:pPr>
-            <a:r>
-              <a:rPr sz="1370" b="1" i="0">
-                <a:solidFill>
-                  <a:srgbClr val="F3F7F9"/>
-                </a:solidFill>
-                <a:latin typeface="Aptos"/>
-              </a:rPr>
-              <a:t>Line of sight</a:t>
-            </a:r>
-          </a:p>
-        </p:txBody>
-      </p:sp>
-      <p:sp>
-        <p:nvSpPr>
-          <p:cNvPr id="37" name="Rounded Rectangle 36"/>
-          <p:cNvSpPr/>
-          <p:nvPr/>
-        </p:nvSpPr>
-        <p:spPr>
-          <a:xfrm>
-            <a:off x="5387339" y="4462272"/>
-            <a:ext cx="1554480" cy="457200"/>
-          </a:xfrm>
-          <a:prstGeom prst="roundRect">
-            <a:avLst/>
-          </a:prstGeom>
-          <a:solidFill>
-            <a:srgbClr val="102738"/>
-          </a:solidFill>
-          <a:ln w="10160">
-            <a:solidFill>
-              <a:srgbClr val="244054"/>
-            </a:solidFill>
-          </a:ln>
-        </p:spPr>
-        <p:style>
-          <a:lnRef idx="1">
-            <a:schemeClr val="accent1"/>
-          </a:lnRef>
-          <a:fillRef idx="3">
-            <a:schemeClr val="accent1"/>
-          </a:fillRef>
-          <a:effectRef idx="2">
-            <a:schemeClr val="accent1"/>
-          </a:effectRef>
-          <a:fontRef idx="minor">
-            <a:schemeClr val="lt1"/>
-          </a:fontRef>
-        </p:style>
-        <p:txBody>
-          <a:bodyPr rtlCol="0" anchor="ctr"/>
-          <a:lstStyle/>
-          <a:p>
-            <a:pPr algn="ctr"/>
-          </a:p>
-        </p:txBody>
-      </p:sp>
-      <p:sp>
-        <p:nvSpPr>
-          <p:cNvPr id="38" name="TextBox 37"/>
-          <p:cNvSpPr txBox="1"/>
-          <p:nvPr/>
-        </p:nvSpPr>
-        <p:spPr>
-          <a:xfrm>
-            <a:off x="5433059" y="4471416"/>
-            <a:ext cx="1463039" cy="438912"/>
-          </a:xfrm>
-          <a:prstGeom prst="rect">
-            <a:avLst/>
-          </a:prstGeom>
-          <a:noFill/>
-        </p:spPr>
-        <p:txBody>
-          <a:bodyPr wrap="square" lIns="0" rIns="0" tIns="0" bIns="0" anchor="ctr">
-            <a:spAutoFit/>
-          </a:bodyPr>
-          <a:lstStyle/>
-          <a:p>
-            <a:pPr algn="ctr">
-              <a:lnSpc>
-                <a:spcPct val="98000"/>
-              </a:lnSpc>
-              <a:spcBef>
-                <a:spcPts val="0"/>
-              </a:spcBef>
-              <a:spcAft>
-                <a:spcPts val="0"/>
-              </a:spcAft>
-            </a:pPr>
-            <a:r>
-              <a:rPr sz="1370" b="1" i="0">
-                <a:solidFill>
-                  <a:srgbClr val="F3F7F9"/>
-                </a:solidFill>
-                <a:latin typeface="Aptos"/>
-              </a:rPr>
-              <a:t>Fresnel zone</a:t>
-            </a:r>
-          </a:p>
-        </p:txBody>
-      </p:sp>
-      <p:sp>
-        <p:nvSpPr>
-          <p:cNvPr id="39" name="Rounded Rectangle 38"/>
-          <p:cNvSpPr/>
-          <p:nvPr/>
-        </p:nvSpPr>
-        <p:spPr>
-          <a:xfrm>
-            <a:off x="7088123" y="4462272"/>
-            <a:ext cx="1874519" cy="457200"/>
-          </a:xfrm>
-          <a:prstGeom prst="roundRect">
-            <a:avLst/>
-          </a:prstGeom>
-          <a:solidFill>
-            <a:srgbClr val="102738"/>
-          </a:solidFill>
-          <a:ln w="10160">
-            <a:solidFill>
-              <a:srgbClr val="244054"/>
-            </a:solidFill>
-          </a:ln>
-        </p:spPr>
-        <p:style>
-          <a:lnRef idx="1">
-            <a:schemeClr val="accent1"/>
-          </a:lnRef>
-          <a:fillRef idx="3">
-            <a:schemeClr val="accent1"/>
-          </a:fillRef>
-          <a:effectRef idx="2">
-            <a:schemeClr val="accent1"/>
-          </a:effectRef>
-          <a:fontRef idx="minor">
-            <a:schemeClr val="lt1"/>
-          </a:fontRef>
-        </p:style>
-        <p:txBody>
-          <a:bodyPr rtlCol="0" anchor="ctr"/>
-          <a:lstStyle/>
-          <a:p>
-            <a:pPr algn="ctr"/>
-          </a:p>
-        </p:txBody>
-      </p:sp>
-      <p:sp>
-        <p:nvSpPr>
-          <p:cNvPr id="40" name="TextBox 39"/>
-          <p:cNvSpPr txBox="1"/>
-          <p:nvPr/>
-        </p:nvSpPr>
-        <p:spPr>
-          <a:xfrm>
-            <a:off x="7133843" y="4471416"/>
-            <a:ext cx="1783079" cy="438912"/>
-          </a:xfrm>
-          <a:prstGeom prst="rect">
-            <a:avLst/>
-          </a:prstGeom>
-          <a:noFill/>
-        </p:spPr>
-        <p:txBody>
-          <a:bodyPr wrap="square" lIns="0" rIns="0" tIns="0" bIns="0" anchor="ctr">
-            <a:spAutoFit/>
-          </a:bodyPr>
-          <a:lstStyle/>
-          <a:p>
-            <a:pPr algn="ctr">
-              <a:lnSpc>
-                <a:spcPct val="98000"/>
-              </a:lnSpc>
-              <a:spcBef>
-                <a:spcPts val="0"/>
-              </a:spcBef>
-              <a:spcAft>
-                <a:spcPts val="0"/>
-              </a:spcAft>
-            </a:pPr>
-            <a:r>
-              <a:rPr sz="1370" b="1" i="0">
-                <a:solidFill>
-                  <a:srgbClr val="F3F7F9"/>
-                </a:solidFill>
-                <a:latin typeface="Aptos"/>
-              </a:rPr>
-              <a:t>Antenna height</a:t>
-            </a:r>
-          </a:p>
-        </p:txBody>
-      </p:sp>
-      <p:sp>
-        <p:nvSpPr>
-          <p:cNvPr id="41" name="Rounded Rectangle 40"/>
-          <p:cNvSpPr/>
-          <p:nvPr/>
-        </p:nvSpPr>
-        <p:spPr>
-          <a:xfrm>
-            <a:off x="9108947" y="4462272"/>
-            <a:ext cx="1033271" cy="457200"/>
-          </a:xfrm>
-          <a:prstGeom prst="roundRect">
-            <a:avLst/>
-          </a:prstGeom>
-          <a:solidFill>
-            <a:srgbClr val="102738"/>
-          </a:solidFill>
-          <a:ln w="10160">
-            <a:solidFill>
-              <a:srgbClr val="244054"/>
-            </a:solidFill>
-          </a:ln>
-        </p:spPr>
-        <p:style>
-          <a:lnRef idx="1">
-            <a:schemeClr val="accent1"/>
-          </a:lnRef>
-          <a:fillRef idx="3">
-            <a:schemeClr val="accent1"/>
-          </a:fillRef>
-          <a:effectRef idx="2">
-            <a:schemeClr val="accent1"/>
-          </a:effectRef>
-          <a:fontRef idx="minor">
-            <a:schemeClr val="lt1"/>
-          </a:fontRef>
-        </p:style>
-        <p:txBody>
-          <a:bodyPr rtlCol="0" anchor="ctr"/>
-          <a:lstStyle/>
-          <a:p>
-            <a:pPr algn="ctr"/>
-          </a:p>
-        </p:txBody>
-      </p:sp>
-      <p:sp>
-        <p:nvSpPr>
-          <p:cNvPr id="42" name="TextBox 41"/>
-          <p:cNvSpPr txBox="1"/>
-          <p:nvPr/>
-        </p:nvSpPr>
-        <p:spPr>
-          <a:xfrm>
-            <a:off x="9154667" y="4471416"/>
-            <a:ext cx="941831" cy="438912"/>
-          </a:xfrm>
-          <a:prstGeom prst="rect">
-            <a:avLst/>
-          </a:prstGeom>
-          <a:noFill/>
-        </p:spPr>
-        <p:txBody>
-          <a:bodyPr wrap="square" lIns="0" rIns="0" tIns="0" bIns="0" anchor="ctr">
-            <a:spAutoFit/>
-          </a:bodyPr>
-          <a:lstStyle/>
-          <a:p>
-            <a:pPr algn="ctr">
-              <a:lnSpc>
-                <a:spcPct val="98000"/>
-              </a:lnSpc>
-              <a:spcBef>
-                <a:spcPts val="0"/>
-              </a:spcBef>
-              <a:spcAft>
-                <a:spcPts val="0"/>
-              </a:spcAft>
-            </a:pPr>
-            <a:r>
-              <a:rPr sz="1370" b="1" i="0">
-                <a:solidFill>
-                  <a:srgbClr val="F3F7F9"/>
-                </a:solidFill>
-                <a:latin typeface="Aptos"/>
-              </a:rPr>
-              <a:t>Gain</a:t>
-            </a:r>
-          </a:p>
-        </p:txBody>
-      </p:sp>
-      <p:cxnSp>
-        <p:nvCxnSpPr>
-          <p:cNvPr id="43" name="Connector 42"/>
-          <p:cNvCxnSpPr/>
-          <p:nvPr/>
-        </p:nvCxnSpPr>
-        <p:spPr>
-          <a:xfrm>
-            <a:off x="658368" y="5193792"/>
-            <a:ext cx="10872216" cy="0"/>
-          </a:xfrm>
-          <a:prstGeom prst="line">
-            <a:avLst/>
-          </a:prstGeom>
-          <a:ln w="10795">
-            <a:solidFill>
-              <a:srgbClr val="244054"/>
-            </a:solidFill>
-          </a:ln>
-        </p:spPr>
-        <p:style>
-          <a:lnRef idx="2">
-            <a:schemeClr val="accent1"/>
-          </a:lnRef>
-          <a:fillRef idx="0">
-            <a:schemeClr val="accent1"/>
-          </a:fillRef>
-          <a:effectRef idx="1">
-            <a:schemeClr val="accent1"/>
-          </a:effectRef>
-          <a:fontRef idx="minor">
-            <a:schemeClr val="tx1"/>
-          </a:fontRef>
-        </p:style>
-      </p:cxnSp>
-      <p:sp>
-        <p:nvSpPr>
           <p:cNvPr id="44" name="Rounded Rectangle 43"/>
           <p:cNvSpPr/>
           <p:nvPr/>
@@ -12220,6 +12194,879 @@
                 <a:latin typeface="Aptos"/>
               </a:rPr>
               <a:t>WorldPop</a:t>
+            </a:r>
+          </a:p>
+        </p:txBody>
+      </p:sp>
+      <p:sp>
+        <p:nvSpPr>
+          <p:cNvPr id="54" name="TextBox 53"/>
+          <p:cNvSpPr txBox="1"/>
+          <p:nvPr/>
+        </p:nvSpPr>
+        <p:spPr>
+          <a:xfrm>
+            <a:off x="658368" y="4133087"/>
+            <a:ext cx="4818888" cy="274320"/>
+          </a:xfrm>
+          <a:prstGeom prst="rect">
+            <a:avLst/>
+          </a:prstGeom>
+          <a:noFill/>
+        </p:spPr>
+        <p:txBody>
+          <a:bodyPr wrap="square" lIns="0" rIns="0" tIns="0" bIns="0" anchor="ctr">
+            <a:spAutoFit/>
+          </a:bodyPr>
+          <a:lstStyle/>
+          <a:p>
+            <a:pPr algn="l">
+              <a:lnSpc>
+                <a:spcPct val="98000"/>
+              </a:lnSpc>
+              <a:spcBef>
+                <a:spcPts val="0"/>
+              </a:spcBef>
+              <a:spcAft>
+                <a:spcPts val="0"/>
+              </a:spcAft>
+            </a:pPr>
+            <a:r>
+              <a:rPr sz="1450" b="1">
+                <a:solidFill>
+                  <a:srgbClr val="F3F7F9"/>
+                </a:solidFill>
+                <a:latin typeface="Aptos"/>
+              </a:rPr>
+              <a:t>Hills and distance can weaken radio signals.</a:t>
+            </a:r>
+          </a:p>
+        </p:txBody>
+      </p:sp>
+      <p:sp>
+        <p:nvSpPr>
+          <p:cNvPr id="55" name="Rectangle 54"/>
+          <p:cNvSpPr/>
+          <p:nvPr/>
+        </p:nvSpPr>
+        <p:spPr>
+          <a:xfrm>
+            <a:off x="658368" y="4425696"/>
+            <a:ext cx="10872216" cy="978408"/>
+          </a:xfrm>
+          <a:prstGeom prst="rect">
+            <a:avLst/>
+          </a:prstGeom>
+          <a:solidFill>
+            <a:srgbClr val="071522"/>
+          </a:solidFill>
+          <a:ln>
+            <a:noFill/>
+          </a:ln>
+        </p:spPr>
+        <p:style>
+          <a:lnRef idx="1">
+            <a:schemeClr val="accent1"/>
+          </a:lnRef>
+          <a:fillRef idx="3">
+            <a:schemeClr val="accent1"/>
+          </a:fillRef>
+          <a:effectRef idx="2">
+            <a:schemeClr val="accent1"/>
+          </a:effectRef>
+          <a:fontRef idx="minor">
+            <a:schemeClr val="lt1"/>
+          </a:fontRef>
+        </p:style>
+        <p:txBody>
+          <a:bodyPr rtlCol="0" anchor="ctr"/>
+          <a:lstStyle/>
+          <a:p>
+            <a:pPr algn="ctr"/>
+          </a:p>
+        </p:txBody>
+      </p:sp>
+      <p:sp>
+        <p:nvSpPr>
+          <p:cNvPr id="56" name="Rounded Rectangle 55"/>
+          <p:cNvSpPr/>
+          <p:nvPr/>
+        </p:nvSpPr>
+        <p:spPr>
+          <a:xfrm>
+            <a:off x="676656" y="4489704"/>
+            <a:ext cx="2075688" cy="832104"/>
+          </a:xfrm>
+          <a:prstGeom prst="roundRect">
+            <a:avLst/>
+          </a:prstGeom>
+          <a:solidFill>
+            <a:srgbClr val="12283A"/>
+          </a:solidFill>
+          <a:ln w="10160">
+            <a:solidFill>
+              <a:srgbClr val="244054"/>
+            </a:solidFill>
+          </a:ln>
+        </p:spPr>
+        <p:style>
+          <a:lnRef idx="1">
+            <a:schemeClr val="accent1"/>
+          </a:lnRef>
+          <a:fillRef idx="3">
+            <a:schemeClr val="accent1"/>
+          </a:fillRef>
+          <a:effectRef idx="2">
+            <a:schemeClr val="accent1"/>
+          </a:effectRef>
+          <a:fontRef idx="minor">
+            <a:schemeClr val="lt1"/>
+          </a:fontRef>
+        </p:style>
+        <p:txBody>
+          <a:bodyPr rtlCol="0" anchor="ctr"/>
+          <a:lstStyle/>
+          <a:p>
+            <a:pPr algn="ctr"/>
+          </a:p>
+        </p:txBody>
+      </p:sp>
+      <p:sp>
+        <p:nvSpPr>
+          <p:cNvPr id="57" name="TextBox 56"/>
+          <p:cNvSpPr txBox="1"/>
+          <p:nvPr/>
+        </p:nvSpPr>
+        <p:spPr>
+          <a:xfrm>
+            <a:off x="768096" y="4553712"/>
+            <a:ext cx="1892807" cy="228600"/>
+          </a:xfrm>
+          <a:prstGeom prst="rect">
+            <a:avLst/>
+          </a:prstGeom>
+          <a:noFill/>
+        </p:spPr>
+        <p:txBody>
+          <a:bodyPr wrap="square" lIns="0" rIns="0" tIns="0" bIns="0" anchor="ctr">
+            <a:spAutoFit/>
+          </a:bodyPr>
+          <a:lstStyle/>
+          <a:p>
+            <a:pPr algn="ctr">
+              <a:lnSpc>
+                <a:spcPct val="98000"/>
+              </a:lnSpc>
+              <a:spcBef>
+                <a:spcPts val="0"/>
+              </a:spcBef>
+              <a:spcAft>
+                <a:spcPts val="0"/>
+              </a:spcAft>
+            </a:pPr>
+            <a:r>
+              <a:rPr sz="1360" b="1">
+                <a:solidFill>
+                  <a:srgbClr val="B9F36C"/>
+                </a:solidFill>
+                <a:latin typeface="Aptos"/>
+              </a:rPr>
+              <a:t>Path loss</a:t>
+            </a:r>
+          </a:p>
+        </p:txBody>
+      </p:sp>
+      <p:sp>
+        <p:nvSpPr>
+          <p:cNvPr id="58" name="TextBox 57"/>
+          <p:cNvSpPr txBox="1"/>
+          <p:nvPr/>
+        </p:nvSpPr>
+        <p:spPr>
+          <a:xfrm>
+            <a:off x="768096" y="4800600"/>
+            <a:ext cx="1892807" cy="438912"/>
+          </a:xfrm>
+          <a:prstGeom prst="rect">
+            <a:avLst/>
+          </a:prstGeom>
+          <a:noFill/>
+        </p:spPr>
+        <p:txBody>
+          <a:bodyPr wrap="square" lIns="0" rIns="0" tIns="0" bIns="0" anchor="ctr">
+            <a:spAutoFit/>
+          </a:bodyPr>
+          <a:lstStyle/>
+          <a:p>
+            <a:pPr algn="ctr">
+              <a:lnSpc>
+                <a:spcPct val="98000"/>
+              </a:lnSpc>
+              <a:spcBef>
+                <a:spcPts val="0"/>
+              </a:spcBef>
+              <a:spcAft>
+                <a:spcPts val="0"/>
+              </a:spcAft>
+            </a:pPr>
+            <a:r>
+              <a:rPr sz="1240" b="0">
+                <a:solidFill>
+                  <a:srgbClr val="F3F7F9"/>
+                </a:solidFill>
+                <a:latin typeface="Aptos"/>
+              </a:rPr>
+              <a:t>Signal weakens</a:t>
+            </a:r>
+          </a:p>
+          <a:p>
+            <a:pPr algn="ctr">
+              <a:lnSpc>
+                <a:spcPct val="98000"/>
+              </a:lnSpc>
+              <a:spcBef>
+                <a:spcPts val="0"/>
+              </a:spcBef>
+              <a:spcAft>
+                <a:spcPts val="0"/>
+              </a:spcAft>
+            </a:pPr>
+            <a:r>
+              <a:rPr sz="1240" b="0">
+                <a:solidFill>
+                  <a:srgbClr val="F3F7F9"/>
+                </a:solidFill>
+                <a:latin typeface="Aptos"/>
+              </a:rPr>
+              <a:t>over distance</a:t>
+            </a:r>
+          </a:p>
+        </p:txBody>
+      </p:sp>
+      <p:sp>
+        <p:nvSpPr>
+          <p:cNvPr id="59" name="Rounded Rectangle 58"/>
+          <p:cNvSpPr/>
+          <p:nvPr/>
+        </p:nvSpPr>
+        <p:spPr>
+          <a:xfrm>
+            <a:off x="2862072" y="4489704"/>
+            <a:ext cx="2075688" cy="832104"/>
+          </a:xfrm>
+          <a:prstGeom prst="roundRect">
+            <a:avLst/>
+          </a:prstGeom>
+          <a:solidFill>
+            <a:srgbClr val="12283A"/>
+          </a:solidFill>
+          <a:ln w="10160">
+            <a:solidFill>
+              <a:srgbClr val="244054"/>
+            </a:solidFill>
+          </a:ln>
+        </p:spPr>
+        <p:style>
+          <a:lnRef idx="1">
+            <a:schemeClr val="accent1"/>
+          </a:lnRef>
+          <a:fillRef idx="3">
+            <a:schemeClr val="accent1"/>
+          </a:fillRef>
+          <a:effectRef idx="2">
+            <a:schemeClr val="accent1"/>
+          </a:effectRef>
+          <a:fontRef idx="minor">
+            <a:schemeClr val="lt1"/>
+          </a:fontRef>
+        </p:style>
+        <p:txBody>
+          <a:bodyPr rtlCol="0" anchor="ctr"/>
+          <a:lstStyle/>
+          <a:p>
+            <a:pPr algn="ctr"/>
+          </a:p>
+        </p:txBody>
+      </p:sp>
+      <p:sp>
+        <p:nvSpPr>
+          <p:cNvPr id="60" name="TextBox 59"/>
+          <p:cNvSpPr txBox="1"/>
+          <p:nvPr/>
+        </p:nvSpPr>
+        <p:spPr>
+          <a:xfrm>
+            <a:off x="2953512" y="4553712"/>
+            <a:ext cx="1892807" cy="228600"/>
+          </a:xfrm>
+          <a:prstGeom prst="rect">
+            <a:avLst/>
+          </a:prstGeom>
+          <a:noFill/>
+        </p:spPr>
+        <p:txBody>
+          <a:bodyPr wrap="square" lIns="0" rIns="0" tIns="0" bIns="0" anchor="ctr">
+            <a:spAutoFit/>
+          </a:bodyPr>
+          <a:lstStyle/>
+          <a:p>
+            <a:pPr algn="ctr">
+              <a:lnSpc>
+                <a:spcPct val="98000"/>
+              </a:lnSpc>
+              <a:spcBef>
+                <a:spcPts val="0"/>
+              </a:spcBef>
+              <a:spcAft>
+                <a:spcPts val="0"/>
+              </a:spcAft>
+            </a:pPr>
+            <a:r>
+              <a:rPr sz="1360" b="1">
+                <a:solidFill>
+                  <a:srgbClr val="B9F36C"/>
+                </a:solidFill>
+                <a:latin typeface="Aptos"/>
+              </a:rPr>
+              <a:t>Line of sight</a:t>
+            </a:r>
+          </a:p>
+        </p:txBody>
+      </p:sp>
+      <p:sp>
+        <p:nvSpPr>
+          <p:cNvPr id="61" name="TextBox 60"/>
+          <p:cNvSpPr txBox="1"/>
+          <p:nvPr/>
+        </p:nvSpPr>
+        <p:spPr>
+          <a:xfrm>
+            <a:off x="2953512" y="4800600"/>
+            <a:ext cx="1892807" cy="438912"/>
+          </a:xfrm>
+          <a:prstGeom prst="rect">
+            <a:avLst/>
+          </a:prstGeom>
+          <a:noFill/>
+        </p:spPr>
+        <p:txBody>
+          <a:bodyPr wrap="square" lIns="0" rIns="0" tIns="0" bIns="0" anchor="ctr">
+            <a:spAutoFit/>
+          </a:bodyPr>
+          <a:lstStyle/>
+          <a:p>
+            <a:pPr algn="ctr">
+              <a:lnSpc>
+                <a:spcPct val="98000"/>
+              </a:lnSpc>
+              <a:spcBef>
+                <a:spcPts val="0"/>
+              </a:spcBef>
+              <a:spcAft>
+                <a:spcPts val="0"/>
+              </a:spcAft>
+            </a:pPr>
+            <a:r>
+              <a:rPr sz="1240" b="0">
+                <a:solidFill>
+                  <a:srgbClr val="F3F7F9"/>
+                </a:solidFill>
+                <a:latin typeface="Aptos"/>
+              </a:rPr>
+              <a:t>Clear path between</a:t>
+            </a:r>
+          </a:p>
+          <a:p>
+            <a:pPr algn="ctr">
+              <a:lnSpc>
+                <a:spcPct val="98000"/>
+              </a:lnSpc>
+              <a:spcBef>
+                <a:spcPts val="0"/>
+              </a:spcBef>
+              <a:spcAft>
+                <a:spcPts val="0"/>
+              </a:spcAft>
+            </a:pPr>
+            <a:r>
+              <a:rPr sz="1240" b="0">
+                <a:solidFill>
+                  <a:srgbClr val="F3F7F9"/>
+                </a:solidFill>
+                <a:latin typeface="Aptos"/>
+              </a:rPr>
+              <a:t>antennas</a:t>
+            </a:r>
+          </a:p>
+        </p:txBody>
+      </p:sp>
+      <p:sp>
+        <p:nvSpPr>
+          <p:cNvPr id="62" name="Rounded Rectangle 61"/>
+          <p:cNvSpPr/>
+          <p:nvPr/>
+        </p:nvSpPr>
+        <p:spPr>
+          <a:xfrm>
+            <a:off x="5047488" y="4489704"/>
+            <a:ext cx="2075688" cy="832104"/>
+          </a:xfrm>
+          <a:prstGeom prst="roundRect">
+            <a:avLst/>
+          </a:prstGeom>
+          <a:solidFill>
+            <a:srgbClr val="12283A"/>
+          </a:solidFill>
+          <a:ln w="10160">
+            <a:solidFill>
+              <a:srgbClr val="244054"/>
+            </a:solidFill>
+          </a:ln>
+        </p:spPr>
+        <p:style>
+          <a:lnRef idx="1">
+            <a:schemeClr val="accent1"/>
+          </a:lnRef>
+          <a:fillRef idx="3">
+            <a:schemeClr val="accent1"/>
+          </a:fillRef>
+          <a:effectRef idx="2">
+            <a:schemeClr val="accent1"/>
+          </a:effectRef>
+          <a:fontRef idx="minor">
+            <a:schemeClr val="lt1"/>
+          </a:fontRef>
+        </p:style>
+        <p:txBody>
+          <a:bodyPr rtlCol="0" anchor="ctr"/>
+          <a:lstStyle/>
+          <a:p>
+            <a:pPr algn="ctr"/>
+          </a:p>
+        </p:txBody>
+      </p:sp>
+      <p:sp>
+        <p:nvSpPr>
+          <p:cNvPr id="63" name="TextBox 62"/>
+          <p:cNvSpPr txBox="1"/>
+          <p:nvPr/>
+        </p:nvSpPr>
+        <p:spPr>
+          <a:xfrm>
+            <a:off x="5138928" y="4553712"/>
+            <a:ext cx="1892807" cy="228600"/>
+          </a:xfrm>
+          <a:prstGeom prst="rect">
+            <a:avLst/>
+          </a:prstGeom>
+          <a:noFill/>
+        </p:spPr>
+        <p:txBody>
+          <a:bodyPr wrap="square" lIns="0" rIns="0" tIns="0" bIns="0" anchor="ctr">
+            <a:spAutoFit/>
+          </a:bodyPr>
+          <a:lstStyle/>
+          <a:p>
+            <a:pPr algn="ctr">
+              <a:lnSpc>
+                <a:spcPct val="98000"/>
+              </a:lnSpc>
+              <a:spcBef>
+                <a:spcPts val="0"/>
+              </a:spcBef>
+              <a:spcAft>
+                <a:spcPts val="0"/>
+              </a:spcAft>
+            </a:pPr>
+            <a:r>
+              <a:rPr sz="1360" b="1">
+                <a:solidFill>
+                  <a:srgbClr val="B9F36C"/>
+                </a:solidFill>
+                <a:latin typeface="Aptos"/>
+              </a:rPr>
+              <a:t>Fresnel zone</a:t>
+            </a:r>
+          </a:p>
+        </p:txBody>
+      </p:sp>
+      <p:sp>
+        <p:nvSpPr>
+          <p:cNvPr id="64" name="TextBox 63"/>
+          <p:cNvSpPr txBox="1"/>
+          <p:nvPr/>
+        </p:nvSpPr>
+        <p:spPr>
+          <a:xfrm>
+            <a:off x="5138928" y="4800600"/>
+            <a:ext cx="1892807" cy="438912"/>
+          </a:xfrm>
+          <a:prstGeom prst="rect">
+            <a:avLst/>
+          </a:prstGeom>
+          <a:noFill/>
+        </p:spPr>
+        <p:txBody>
+          <a:bodyPr wrap="square" lIns="0" rIns="0" tIns="0" bIns="0" anchor="ctr">
+            <a:spAutoFit/>
+          </a:bodyPr>
+          <a:lstStyle/>
+          <a:p>
+            <a:pPr algn="ctr">
+              <a:lnSpc>
+                <a:spcPct val="98000"/>
+              </a:lnSpc>
+              <a:spcBef>
+                <a:spcPts val="0"/>
+              </a:spcBef>
+              <a:spcAft>
+                <a:spcPts val="0"/>
+              </a:spcAft>
+            </a:pPr>
+            <a:r>
+              <a:rPr sz="1240" b="0">
+                <a:solidFill>
+                  <a:srgbClr val="F3F7F9"/>
+                </a:solidFill>
+                <a:latin typeface="Aptos"/>
+              </a:rPr>
+              <a:t>Keep space clear</a:t>
+            </a:r>
+          </a:p>
+          <a:p>
+            <a:pPr algn="ctr">
+              <a:lnSpc>
+                <a:spcPct val="98000"/>
+              </a:lnSpc>
+              <a:spcBef>
+                <a:spcPts val="0"/>
+              </a:spcBef>
+              <a:spcAft>
+                <a:spcPts val="0"/>
+              </a:spcAft>
+            </a:pPr>
+            <a:r>
+              <a:rPr sz="1240" b="0">
+                <a:solidFill>
+                  <a:srgbClr val="F3F7F9"/>
+                </a:solidFill>
+                <a:latin typeface="Aptos"/>
+              </a:rPr>
+              <a:t>around the path</a:t>
+            </a:r>
+          </a:p>
+        </p:txBody>
+      </p:sp>
+      <p:sp>
+        <p:nvSpPr>
+          <p:cNvPr id="65" name="Rounded Rectangle 64"/>
+          <p:cNvSpPr/>
+          <p:nvPr/>
+        </p:nvSpPr>
+        <p:spPr>
+          <a:xfrm>
+            <a:off x="7232904" y="4489704"/>
+            <a:ext cx="2075688" cy="832104"/>
+          </a:xfrm>
+          <a:prstGeom prst="roundRect">
+            <a:avLst/>
+          </a:prstGeom>
+          <a:solidFill>
+            <a:srgbClr val="12283A"/>
+          </a:solidFill>
+          <a:ln w="10160">
+            <a:solidFill>
+              <a:srgbClr val="244054"/>
+            </a:solidFill>
+          </a:ln>
+        </p:spPr>
+        <p:style>
+          <a:lnRef idx="1">
+            <a:schemeClr val="accent1"/>
+          </a:lnRef>
+          <a:fillRef idx="3">
+            <a:schemeClr val="accent1"/>
+          </a:fillRef>
+          <a:effectRef idx="2">
+            <a:schemeClr val="accent1"/>
+          </a:effectRef>
+          <a:fontRef idx="minor">
+            <a:schemeClr val="lt1"/>
+          </a:fontRef>
+        </p:style>
+        <p:txBody>
+          <a:bodyPr rtlCol="0" anchor="ctr"/>
+          <a:lstStyle/>
+          <a:p>
+            <a:pPr algn="ctr"/>
+          </a:p>
+        </p:txBody>
+      </p:sp>
+      <p:sp>
+        <p:nvSpPr>
+          <p:cNvPr id="66" name="TextBox 65"/>
+          <p:cNvSpPr txBox="1"/>
+          <p:nvPr/>
+        </p:nvSpPr>
+        <p:spPr>
+          <a:xfrm>
+            <a:off x="7324344" y="4553712"/>
+            <a:ext cx="1892807" cy="228600"/>
+          </a:xfrm>
+          <a:prstGeom prst="rect">
+            <a:avLst/>
+          </a:prstGeom>
+          <a:noFill/>
+        </p:spPr>
+        <p:txBody>
+          <a:bodyPr wrap="square" lIns="0" rIns="0" tIns="0" bIns="0" anchor="ctr">
+            <a:spAutoFit/>
+          </a:bodyPr>
+          <a:lstStyle/>
+          <a:p>
+            <a:pPr algn="ctr">
+              <a:lnSpc>
+                <a:spcPct val="98000"/>
+              </a:lnSpc>
+              <a:spcBef>
+                <a:spcPts val="0"/>
+              </a:spcBef>
+              <a:spcAft>
+                <a:spcPts val="0"/>
+              </a:spcAft>
+            </a:pPr>
+            <a:r>
+              <a:rPr sz="1360" b="1">
+                <a:solidFill>
+                  <a:srgbClr val="B9F36C"/>
+                </a:solidFill>
+                <a:latin typeface="Aptos"/>
+              </a:rPr>
+              <a:t>Antenna height</a:t>
+            </a:r>
+          </a:p>
+        </p:txBody>
+      </p:sp>
+      <p:sp>
+        <p:nvSpPr>
+          <p:cNvPr id="67" name="TextBox 66"/>
+          <p:cNvSpPr txBox="1"/>
+          <p:nvPr/>
+        </p:nvSpPr>
+        <p:spPr>
+          <a:xfrm>
+            <a:off x="7324344" y="4800600"/>
+            <a:ext cx="1892807" cy="438912"/>
+          </a:xfrm>
+          <a:prstGeom prst="rect">
+            <a:avLst/>
+          </a:prstGeom>
+          <a:noFill/>
+        </p:spPr>
+        <p:txBody>
+          <a:bodyPr wrap="square" lIns="0" rIns="0" tIns="0" bIns="0" anchor="ctr">
+            <a:spAutoFit/>
+          </a:bodyPr>
+          <a:lstStyle/>
+          <a:p>
+            <a:pPr algn="ctr">
+              <a:lnSpc>
+                <a:spcPct val="98000"/>
+              </a:lnSpc>
+              <a:spcBef>
+                <a:spcPts val="0"/>
+              </a:spcBef>
+              <a:spcAft>
+                <a:spcPts val="0"/>
+              </a:spcAft>
+            </a:pPr>
+            <a:r>
+              <a:rPr sz="1240" b="0">
+                <a:solidFill>
+                  <a:srgbClr val="F3F7F9"/>
+                </a:solidFill>
+                <a:latin typeface="Aptos"/>
+              </a:rPr>
+              <a:t>Higher antennas clear</a:t>
+            </a:r>
+          </a:p>
+          <a:p>
+            <a:pPr algn="ctr">
+              <a:lnSpc>
+                <a:spcPct val="98000"/>
+              </a:lnSpc>
+              <a:spcBef>
+                <a:spcPts val="0"/>
+              </a:spcBef>
+              <a:spcAft>
+                <a:spcPts val="0"/>
+              </a:spcAft>
+            </a:pPr>
+            <a:r>
+              <a:rPr sz="1240" b="0">
+                <a:solidFill>
+                  <a:srgbClr val="F3F7F9"/>
+                </a:solidFill>
+                <a:latin typeface="Aptos"/>
+              </a:rPr>
+              <a:t>more obstacles</a:t>
+            </a:r>
+          </a:p>
+        </p:txBody>
+      </p:sp>
+      <p:sp>
+        <p:nvSpPr>
+          <p:cNvPr id="68" name="Rounded Rectangle 67"/>
+          <p:cNvSpPr/>
+          <p:nvPr/>
+        </p:nvSpPr>
+        <p:spPr>
+          <a:xfrm>
+            <a:off x="9418320" y="4489704"/>
+            <a:ext cx="2075688" cy="832104"/>
+          </a:xfrm>
+          <a:prstGeom prst="roundRect">
+            <a:avLst/>
+          </a:prstGeom>
+          <a:solidFill>
+            <a:srgbClr val="12283A"/>
+          </a:solidFill>
+          <a:ln w="10160">
+            <a:solidFill>
+              <a:srgbClr val="244054"/>
+            </a:solidFill>
+          </a:ln>
+        </p:spPr>
+        <p:style>
+          <a:lnRef idx="1">
+            <a:schemeClr val="accent1"/>
+          </a:lnRef>
+          <a:fillRef idx="3">
+            <a:schemeClr val="accent1"/>
+          </a:fillRef>
+          <a:effectRef idx="2">
+            <a:schemeClr val="accent1"/>
+          </a:effectRef>
+          <a:fontRef idx="minor">
+            <a:schemeClr val="lt1"/>
+          </a:fontRef>
+        </p:style>
+        <p:txBody>
+          <a:bodyPr rtlCol="0" anchor="ctr"/>
+          <a:lstStyle/>
+          <a:p>
+            <a:pPr algn="ctr"/>
+          </a:p>
+        </p:txBody>
+      </p:sp>
+      <p:sp>
+        <p:nvSpPr>
+          <p:cNvPr id="69" name="TextBox 68"/>
+          <p:cNvSpPr txBox="1"/>
+          <p:nvPr/>
+        </p:nvSpPr>
+        <p:spPr>
+          <a:xfrm>
+            <a:off x="9509760" y="4553712"/>
+            <a:ext cx="1892807" cy="228600"/>
+          </a:xfrm>
+          <a:prstGeom prst="rect">
+            <a:avLst/>
+          </a:prstGeom>
+          <a:noFill/>
+        </p:spPr>
+        <p:txBody>
+          <a:bodyPr wrap="square" lIns="0" rIns="0" tIns="0" bIns="0" anchor="ctr">
+            <a:spAutoFit/>
+          </a:bodyPr>
+          <a:lstStyle/>
+          <a:p>
+            <a:pPr algn="ctr">
+              <a:lnSpc>
+                <a:spcPct val="98000"/>
+              </a:lnSpc>
+              <a:spcBef>
+                <a:spcPts val="0"/>
+              </a:spcBef>
+              <a:spcAft>
+                <a:spcPts val="0"/>
+              </a:spcAft>
+            </a:pPr>
+            <a:r>
+              <a:rPr sz="1360" b="1">
+                <a:solidFill>
+                  <a:srgbClr val="B9F36C"/>
+                </a:solidFill>
+                <a:latin typeface="Aptos"/>
+              </a:rPr>
+              <a:t>Gain</a:t>
+            </a:r>
+          </a:p>
+        </p:txBody>
+      </p:sp>
+      <p:sp>
+        <p:nvSpPr>
+          <p:cNvPr id="70" name="TextBox 69"/>
+          <p:cNvSpPr txBox="1"/>
+          <p:nvPr/>
+        </p:nvSpPr>
+        <p:spPr>
+          <a:xfrm>
+            <a:off x="9509760" y="4800600"/>
+            <a:ext cx="1892807" cy="438912"/>
+          </a:xfrm>
+          <a:prstGeom prst="rect">
+            <a:avLst/>
+          </a:prstGeom>
+          <a:noFill/>
+        </p:spPr>
+        <p:txBody>
+          <a:bodyPr wrap="square" lIns="0" rIns="0" tIns="0" bIns="0" anchor="ctr">
+            <a:spAutoFit/>
+          </a:bodyPr>
+          <a:lstStyle/>
+          <a:p>
+            <a:pPr algn="ctr">
+              <a:lnSpc>
+                <a:spcPct val="98000"/>
+              </a:lnSpc>
+              <a:spcBef>
+                <a:spcPts val="0"/>
+              </a:spcBef>
+              <a:spcAft>
+                <a:spcPts val="0"/>
+              </a:spcAft>
+            </a:pPr>
+            <a:r>
+              <a:rPr sz="1240" b="0">
+                <a:solidFill>
+                  <a:srgbClr val="F3F7F9"/>
+                </a:solidFill>
+                <a:latin typeface="Aptos"/>
+              </a:rPr>
+              <a:t>Focus signal</a:t>
+            </a:r>
+          </a:p>
+          <a:p>
+            <a:pPr algn="ctr">
+              <a:lnSpc>
+                <a:spcPct val="98000"/>
+              </a:lnSpc>
+              <a:spcBef>
+                <a:spcPts val="0"/>
+              </a:spcBef>
+              <a:spcAft>
+                <a:spcPts val="0"/>
+              </a:spcAft>
+            </a:pPr>
+            <a:r>
+              <a:rPr sz="1240" b="0">
+                <a:solidFill>
+                  <a:srgbClr val="F3F7F9"/>
+                </a:solidFill>
+                <a:latin typeface="Aptos"/>
+              </a:rPr>
+              <a:t>toward the village</a:t>
             </a:r>
           </a:p>
         </p:txBody>
@@ -14696,6 +15543,51 @@
           </a:p>
         </p:txBody>
       </p:sp>
+      <p:sp>
+        <p:nvSpPr>
+          <p:cNvPr id="61" name="TextBox 60"/>
+          <p:cNvSpPr txBox="1"/>
+          <p:nvPr/>
+        </p:nvSpPr>
+        <p:spPr>
+          <a:xfrm>
+            <a:off x="658368" y="4453128"/>
+            <a:ext cx="10872216" cy="228600"/>
+          </a:xfrm>
+          <a:prstGeom prst="rect">
+            <a:avLst/>
+          </a:prstGeom>
+          <a:noFill/>
+        </p:spPr>
+        <p:txBody>
+          <a:bodyPr wrap="square" lIns="0" rIns="0" tIns="0" bIns="0" anchor="ctr">
+            <a:spAutoFit/>
+          </a:bodyPr>
+          <a:lstStyle/>
+          <a:p>
+            <a:pPr algn="ctr">
+              <a:lnSpc>
+                <a:spcPct val="98000"/>
+              </a:lnSpc>
+              <a:spcBef>
+                <a:spcPts val="0"/>
+              </a:spcBef>
+              <a:spcAft>
+                <a:spcPts val="0"/>
+              </a:spcAft>
+            </a:pPr>
+            <a:r>
+              <a:rPr sz="1420" b="1">
+                <a:solidFill>
+                  <a:srgbClr val="9AAFC0"/>
+                </a:solidFill>
+                <a:latin typeface="Aptos"/>
+              </a:rPr>
+              <a:t>Better coverage planning supports warnings and learning.</a:t>
+            </a:r>
+          </a:p>
+        </p:txBody>
+      </p:sp>
     </p:spTree>
   </p:cSld>
   <p:clrMapOvr>
@@ -16201,14 +17093,59 @@
       </p:cxnSp>
       <p:sp>
         <p:nvSpPr>
-          <p:cNvPr id="36" name="TextBox 35"/>
+          <p:cNvPr id="37" name="TextBox 36"/>
           <p:cNvSpPr txBox="1"/>
           <p:nvPr/>
         </p:nvSpPr>
         <p:spPr>
           <a:xfrm>
-            <a:off x="6858000" y="5522976"/>
-            <a:ext cx="4389120" cy="356616"/>
+            <a:off x="1554480" y="4590288"/>
+            <a:ext cx="4828032" cy="219456"/>
+          </a:xfrm>
+          <a:prstGeom prst="rect">
+            <a:avLst/>
+          </a:prstGeom>
+          <a:noFill/>
+        </p:spPr>
+        <p:txBody>
+          <a:bodyPr wrap="square" lIns="0" rIns="0" tIns="0" bIns="0" anchor="ctr">
+            <a:spAutoFit/>
+          </a:bodyPr>
+          <a:lstStyle/>
+          <a:p>
+            <a:pPr algn="l">
+              <a:lnSpc>
+                <a:spcPct val="98000"/>
+              </a:lnSpc>
+              <a:spcBef>
+                <a:spcPts val="0"/>
+              </a:spcBef>
+              <a:spcAft>
+                <a:spcPts val="0"/>
+              </a:spcAft>
+            </a:pPr>
+            <a:r>
+              <a:rPr sz="1400" b="1">
+                <a:solidFill>
+                  <a:srgbClr val="74D7A5"/>
+                </a:solidFill>
+                <a:latin typeface="Aptos"/>
+              </a:rPr>
+              <a:t>Start small. Measure results. Then expand.</a:t>
+            </a:r>
+          </a:p>
+        </p:txBody>
+      </p:sp>
+      <p:sp>
+        <p:nvSpPr>
+          <p:cNvPr id="38" name="TextBox 37"/>
+          <p:cNvSpPr txBox="1"/>
+          <p:nvPr/>
+        </p:nvSpPr>
+        <p:spPr>
+          <a:xfrm>
+            <a:off x="6858000" y="5596128"/>
+            <a:ext cx="4389120" cy="265176"/>
           </a:xfrm>
           <a:prstGeom prst="rect">
             <a:avLst/>
@@ -16233,13 +17170,49 @@
               </a:spcAft>
             </a:pPr>
             <a:r>
-              <a:rPr sz="1470" b="1" i="0">
+              <a:rPr sz="1350" b="1">
                 <a:solidFill>
                   <a:srgbClr val="B9F36C"/>
                 </a:solidFill>
                 <a:latin typeface="Aptos"/>
+                <a:hlinkClick r:id="rId4"/>
               </a:rPr>
-              <a:t>[email]   ·   [phone]</a:t>
+              <a:t>itxsachin6729@gmail.com</a:t>
+            </a:r>
+          </a:p>
+        </p:txBody>
+      </p:sp>
+      <p:sp>
+        <p:nvSpPr>
+          <p:cNvPr id="39" name="TextBox 38"/>
+          <p:cNvSpPr txBox="1"/>
+          <p:nvPr/>
+        </p:nvSpPr>
+        <p:spPr>
+          <a:xfrm>
+            <a:off x="6858000" y="5458968"/>
+            <a:ext cx="4389120" cy="146304"/>
+          </a:xfrm>
+          <a:prstGeom prst="rect">
+            <a:avLst/>
+          </a:prstGeom>
+          <a:noFill/>
+        </p:spPr>
+        <p:txBody>
+          <a:bodyPr wrap="none" lIns="0" rIns="0" tIns="0" bIns="0" anchor="t">
+            <a:spAutoFit/>
+          </a:bodyPr>
+          <a:lstStyle/>
+          <a:p>
+            <a:pPr algn="ctr"/>
+            <a:r>
+              <a:rPr sz="950" b="1">
+                <a:solidFill>
+                  <a:srgbClr val="9AAFC0"/>
+                </a:solidFill>
+                <a:latin typeface="Aptos"/>
+              </a:rPr>
+              <a:t>EMAIL</a:t>
             </a:r>
           </a:p>
         </p:txBody>

</xml_diff>